<commit_message>
[ai] team credits in README, AI_USAGE and the deck; deck statuses: mandates released, SDK on npm, 547 tests
</commit_message>
<xml_diff>
--- a/docs/pitch/kovan-judge-backup.pptx
+++ b/docs/pitch/kovan-judge-backup.pptx
@@ -788,7 +788,7 @@
           </a:p>
           <a:p>
             <a:r>
-              <a:t>Native Kovan mandates: implemented and tested locally, not deployed. They add owner-approved exact/budget grants, payment IDs, expiry and receipts, and intersect with covenant limits. They are not AP2 signed credentials, MCP, A2A, escrow or delivery verification. New compatible contracts and agents plus a funded facilitator rehearsal are required.</a:t>
+              <a:t>Native Kovan mandates: released on testnet on 2026-10-26 (policy CAQAHBSHKEUQCXUMFCD65GNRTKDNE5A7HOHA7XVOKVKTV4H4O63OWJYB; new pools use the release) and rehearsed end to end on an isolated pool with a direct payment. Facilitator acceptance of the mandate envelope over x402 is not yet rehearsed. They add owner-approved exact/budget grants, payment IDs, expiry and receipts, and intersect with covenant limits. They are not AP2 signed credentials, MCP, A2A, escrow or delivery verification. New compatible contracts and agents plus a funded facilitator rehearsal are required.</a:t>
             </a:r>
           </a:p>
           <a:p>
@@ -798,7 +798,7 @@
           </a:p>
           <a:p>
             <a:r>
-              <a:t>SDK: @kovan-protocol/sdk is local and packable, not yet published to npm. Agent guides/plugin and owner signing flows exist. Publication and hosted-flow verification should be checked before a live announcement.</a:t>
+              <a:t>SDK: @kovan-protocol/sdk@0.1.0 is published on npm. Agent guides/plugin and owner signing flows exist.</a:t>
             </a:r>
           </a:p>
           <a:p>
@@ -883,7 +883,7 @@
           </a:p>
           <a:p>
             <a:r>
-              <a:t>Test count is 151 Rust + 266 dashboard + 73 SDK = 490, from docs/MANDATES.md verification on 2026-10-26. This is a documented local snapshot, not tests re-run during deck production. It includes undeployed mandates and yield work, and excludes an optional ignored external fixture test. It does not establish an audit or a live production deployment.</a:t>
+              <a:t>Test count is 152 Rust + 267 dashboard + 79 SDK + 49 signer = 547, run on main on 2026-10-26 (README, Testing). It includes the released mandates and the unactivated yield work, and excludes an optional ignored external fixture test. It does not establish an audit or a live production deployment.</a:t>
             </a:r>
           </a:p>
           <a:p>
@@ -8306,11 +8306,11 @@
             <a:r>
               <a:rPr sz="1700" b="1">
                 <a:solidFill>
-                  <a:srgbClr val="014CFE"/>
+                  <a:srgbClr val="167248"/>
                 </a:solidFill>
                 <a:latin typeface="JetBrains Mono"/>
               </a:rPr>
-              <a:t>LOCAL BUILD</a:t>
+              <a:t>TESTNET</a:t>
             </a:r>
           </a:p>
         </p:txBody>
@@ -8400,7 +8400,7 @@
                 </a:solidFill>
                 <a:latin typeface="Inter"/>
               </a:rPr>
-              <a:t>Exact or budget grants; durable receipts.</a:t>
+              <a:t>Exact or budget grants; on-chain receipts. Released 26 Oct.</a:t>
             </a:r>
           </a:p>
         </p:txBody>
@@ -8742,7 +8742,7 @@
                 </a:solidFill>
                 <a:latin typeface="Inter"/>
               </a:rPr>
-              <a:t>Publish SDK; rehearse new deployments.</a:t>
+              <a:t>SDK on npm; x402 rehearsal on the new release; pilots.</a:t>
             </a:r>
           </a:p>
         </p:txBody>
@@ -9397,7 +9397,7 @@
                 </a:solidFill>
                 <a:latin typeface="Manrope"/>
               </a:rPr>
-              <a:t>490</a:t>
+              <a:t>547</a:t>
             </a:r>
           </a:p>
         </p:txBody>
@@ -9442,7 +9442,7 @@
                 </a:solidFill>
                 <a:latin typeface="Inter"/>
               </a:rPr>
-              <a:t>local tests documented</a:t>
+              <a:t>tests passing on main</a:t>
             </a:r>
           </a:p>
         </p:txBody>
@@ -9487,7 +9487,7 @@
                 </a:solidFill>
                 <a:latin typeface="Inter"/>
               </a:rPr>
-              <a:t>151 contracts</a:t>
+              <a:t>152 contracts</a:t>
             </a:r>
           </a:p>
           <a:p>
@@ -9509,7 +9509,7 @@
                 </a:solidFill>
                 <a:latin typeface="Inter"/>
               </a:rPr>
-              <a:t>266 dashboard</a:t>
+              <a:t>267 dashboard</a:t>
             </a:r>
           </a:p>
           <a:p>
@@ -9531,7 +9531,7 @@
                 </a:solidFill>
                 <a:latin typeface="Inter"/>
               </a:rPr>
-              <a:t>73 SDK</a:t>
+              <a:t>79 SDK · 49 signer</a:t>
             </a:r>
           </a:p>
         </p:txBody>
@@ -10059,7 +10059,7 @@
                 </a:solidFill>
                 <a:latin typeface="Inter"/>
               </a:rPr>
-              <a:t>490 = documented 2026-10-26 snapshot in docs/MANDATES.md; includes undeployed code, excludes one optional ignored test.</a:t>
+              <a:t>547 = test run on main, 2026-10-26: 152 Rust, 267 dashboard, 79 SDK, 49 signer; excludes one optional ignored fixture test and six opt-in network tests.</a:t>
             </a:r>
           </a:p>
         </p:txBody>
@@ -11102,7 +11102,7 @@
                 </a:solidFill>
                 <a:latin typeface="Inter"/>
               </a:rPr>
-              <a:t>@kovan-protocol/sdk is local and packable; npm publication is pending. Guide: kovan-protocol.vercel.app/agent.md</a:t>
+              <a:t>@kovan-protocol/sdk@0.1.0 is on npm. Guide: kovan-protocol.vercel.app/agent.md</a:t>
             </a:r>
           </a:p>
         </p:txBody>

</xml_diff>